<commit_message>
docs: measured results from a full live run
98 companies, 91 enriched, 6 qualified leads, 11 named decision-makers,
11 drafted emails — 6.2 min, $0.59, $0.098 per qualified lead.
Down from 29.7 min and 185 LLM calls before the concurrency and
rationale-gating work, with identical lead output.
</commit_message>
<xml_diff>
--- a/docs/Tedlar-Lead-Agent.pptx
+++ b/docs/Tedlar-Lead-Agent.pptx
@@ -2152,7 +2152,7 @@
                 <a:ea typeface="Cambria" pitchFamily="34" charset="-122"/>
                 <a:cs typeface="Cambria" pitchFamily="34" charset="-120"/>
               </a:rPr>
-              <a:t>54</a:t>
+              <a:t>98</a:t>
             </a:r>
             <a:endParaRPr lang="en-US" sz="4400" dirty="0"/>
           </a:p>
@@ -2230,7 +2230,7 @@
                 <a:ea typeface="Cambria" pitchFamily="34" charset="-122"/>
                 <a:cs typeface="Cambria" pitchFamily="34" charset="-120"/>
               </a:rPr>
-              <a:t>87</a:t>
+              <a:t>128</a:t>
             </a:r>
             <a:endParaRPr lang="en-US" sz="4400" dirty="0"/>
           </a:p>
@@ -6948,7 +6948,7 @@
                 <a:ea typeface="Cambria" pitchFamily="34" charset="-122"/>
                 <a:cs typeface="Cambria" pitchFamily="34" charset="-120"/>
               </a:rPr>
-              <a:t>54</a:t>
+              <a:t>98</a:t>
             </a:r>
             <a:endParaRPr lang="en-US" sz="4000" dirty="0"/>
           </a:p>
@@ -7048,7 +7048,7 @@
                 <a:ea typeface="Cambria" pitchFamily="34" charset="-122"/>
                 <a:cs typeface="Cambria" pitchFamily="34" charset="-120"/>
               </a:rPr>
-              <a:t>47</a:t>
+              <a:t>91</a:t>
             </a:r>
             <a:endParaRPr lang="en-US" sz="4000" dirty="0"/>
           </a:p>
@@ -7148,7 +7148,7 @@
                 <a:ea typeface="Cambria" pitchFamily="34" charset="-122"/>
                 <a:cs typeface="Cambria" pitchFamily="34" charset="-120"/>
               </a:rPr>
-              <a:t>10</a:t>
+              <a:t>11</a:t>
             </a:r>
             <a:endParaRPr lang="en-US" sz="4000" dirty="0"/>
           </a:p>
@@ -7248,7 +7248,7 @@
                 <a:ea typeface="Cambria" pitchFamily="34" charset="-122"/>
                 <a:cs typeface="Cambria" pitchFamily="34" charset="-120"/>
               </a:rPr>
-              <a:t>87</a:t>
+              <a:t>128</a:t>
             </a:r>
             <a:endParaRPr lang="en-US" sz="4000" dirty="0"/>
           </a:p>
@@ -7469,23 +7469,23 @@
         <p:spPr>
           <a:xfrm>
             <a:off x="960120" y="5532120"/>
-            <a:ext cx="10241280" cy="548640"/>
-          </a:xfrm>
-          <a:prstGeom prst="rect">
-            <a:avLst/>
-          </a:prstGeom>
-          <a:noFill/>
-          <a:ln/>
-        </p:spPr>
-        <p:txBody>
-          <a:bodyPr wrap="square" lIns="0" tIns="0" rIns="0" bIns="0" rtlCol="0" anchor="ctr"/>
-          <a:lstStyle/>
-          <a:p>
-            <a:pPr indent="0" marL="0">
-              <a:buNone/>
-            </a:pPr>
-            <a:r>
-              <a:rPr lang="en-US" sz="1300" dirty="0">
+            <a:ext cx="10241280" cy="640080"/>
+          </a:xfrm>
+          <a:prstGeom prst="rect">
+            <a:avLst/>
+          </a:prstGeom>
+          <a:noFill/>
+          <a:ln/>
+        </p:spPr>
+        <p:txBody>
+          <a:bodyPr wrap="square" lIns="0" tIns="0" rIns="0" bIns="0" rtlCol="0" anchor="ctr"/>
+          <a:lstStyle/>
+          <a:p>
+            <a:pPr indent="0" marL="0">
+              <a:buNone/>
+            </a:pPr>
+            <a:r>
+              <a:rPr lang="en-US" sz="1250" dirty="0">
                 <a:solidFill>
                   <a:srgbClr val="0B1F26"/>
                 </a:solidFill>
@@ -7493,9 +7493,9 @@
                 <a:ea typeface="Calibri" pitchFamily="34" charset="-122"/>
                 <a:cs typeface="Calibri" pitchFamily="34" charset="-120"/>
               </a:rPr>
-              <a:t>Runs clean with no API keys at all. Two keys — Anthropic and a search provider — turn keyword fallbacks into model-read enrichment and real search recall.</a:t>
-            </a:r>
-            <a:endParaRPr lang="en-US" sz="1300" dirty="0"/>
+              <a:t>Last run: 108 LLM calls, $0.59 total, $0.10 per qualified lead. Runs clean with no API keys at all; each provider has a deterministic fallback, and `app.preflight` verifies every key before a run spends one.</a:t>
+            </a:r>
+            <a:endParaRPr lang="en-US" sz="1250" dirty="0"/>
           </a:p>
         </p:txBody>
       </p:sp>

</xml_diff>

<commit_message>
chore: fresh live run on the current pipeline
94 companies, 88 enriched, 5 tier-B leads, 9 named decision-makers,
9 drafted emails in 5.5 min for $0.55 ($0.11 per qualified lead).

First run to exercise the surname guard: the previous data listed
'Alan Fellers, Director of Conflicts of Interest Programs' as a Fellers
contact purely on a surname match; this run returns Doug Smith, VP at
FELLERS instead.
</commit_message>
<xml_diff>
--- a/docs/Tedlar-Lead-Agent.pptx
+++ b/docs/Tedlar-Lead-Agent.pptx
@@ -2152,7 +2152,7 @@
                 <a:ea typeface="Cambria" pitchFamily="34" charset="-122"/>
                 <a:cs typeface="Cambria" pitchFamily="34" charset="-120"/>
               </a:rPr>
-              <a:t>98</a:t>
+              <a:t>94</a:t>
             </a:r>
             <a:endParaRPr lang="en-US" sz="4400" dirty="0"/>
           </a:p>
@@ -6948,7 +6948,7 @@
                 <a:ea typeface="Cambria" pitchFamily="34" charset="-122"/>
                 <a:cs typeface="Cambria" pitchFamily="34" charset="-120"/>
               </a:rPr>
-              <a:t>98</a:t>
+              <a:t>94</a:t>
             </a:r>
             <a:endParaRPr lang="en-US" sz="4000" dirty="0"/>
           </a:p>
@@ -7048,7 +7048,7 @@
                 <a:ea typeface="Cambria" pitchFamily="34" charset="-122"/>
                 <a:cs typeface="Cambria" pitchFamily="34" charset="-120"/>
               </a:rPr>
-              <a:t>91</a:t>
+              <a:t>88</a:t>
             </a:r>
             <a:endParaRPr lang="en-US" sz="4000" dirty="0"/>
           </a:p>
@@ -7493,7 +7493,7 @@
                 <a:ea typeface="Calibri" pitchFamily="34" charset="-122"/>
                 <a:cs typeface="Calibri" pitchFamily="34" charset="-120"/>
               </a:rPr>
-              <a:t>Last run: 108 LLM calls, $0.59 total, $0.10 per qualified lead. Runs clean with no API keys at all; each provider has a deterministic fallback, and `app.preflight` verifies every key before a run spends one.</a:t>
+              <a:t>Last run: 102 LLM calls, $0.55 total, $0.11 per qualified lead. Runs clean with no API keys at all; each provider has a deterministic fallback, and `app.preflight` verifies every key before a run spends one.</a:t>
             </a:r>
             <a:endParaRPr lang="en-US" sz="1250" dirty="0"/>
           </a:p>

</xml_diff>

<commit_message>
docs: sync deliverables to current run data
results.json regenerated from leads.db: 97 companies, 90 enriched,
32 contacts, 29 drafts, 108 LLM calls, $0.63. Deck, PDF, write-up and
README carried the previous snapshot's 95/89/27/24 and disagreed with
the dashboard. Pin pptxgenjs so build_deck.js is reproducible.

Co-Authored-By: Claude Opus 5 <noreply@anthropic.com>
</commit_message>
<xml_diff>
--- a/docs/Tedlar-Lead-Agent.pptx
+++ b/docs/Tedlar-Lead-Agent.pptx
@@ -2152,7 +2152,7 @@
                 <a:ea typeface="Cambria" pitchFamily="34" charset="-122"/>
                 <a:cs typeface="Cambria" pitchFamily="34" charset="-120"/>
               </a:rPr>
-              <a:t>95</a:t>
+              <a:t>97</a:t>
             </a:r>
             <a:endParaRPr lang="en-US" sz="4400" dirty="0"/>
           </a:p>
@@ -6948,7 +6948,7 @@
                 <a:ea typeface="Cambria" pitchFamily="34" charset="-122"/>
                 <a:cs typeface="Cambria" pitchFamily="34" charset="-120"/>
               </a:rPr>
-              <a:t>95</a:t>
+              <a:t>97</a:t>
             </a:r>
             <a:endParaRPr lang="en-US" sz="4000" dirty="0"/>
           </a:p>
@@ -7048,7 +7048,7 @@
                 <a:ea typeface="Cambria" pitchFamily="34" charset="-122"/>
                 <a:cs typeface="Cambria" pitchFamily="34" charset="-120"/>
               </a:rPr>
-              <a:t>89</a:t>
+              <a:t>90</a:t>
             </a:r>
             <a:endParaRPr lang="en-US" sz="4000" dirty="0"/>
           </a:p>
@@ -7493,7 +7493,7 @@
                 <a:ea typeface="Calibri" pitchFamily="34" charset="-122"/>
                 <a:cs typeface="Calibri" pitchFamily="34" charset="-120"/>
               </a:rPr>
-              <a:t>Last run: 129 LLM calls, $0.85 total, $0.05 per qualified lead. Runs clean with no API keys at all; each provider has a deterministic fallback, and `app.preflight` verifies every key before a run spends one.</a:t>
+              <a:t>Last run: 108 LLM calls, $0.63 total, $0.04 per qualified lead. Runs clean with no API keys at all; each provider has a deterministic fallback, and `app.preflight` verifies every key before a run spends one.</a:t>
             </a:r>
             <a:endParaRPr lang="en-US" sz="1250" dirty="0"/>
           </a:p>

</xml_diff>